<commit_message>
fix: maquetación de la presentación tras la revisión visual
</commit_message>
<xml_diff>
--- a/entregables/presentacion_comite_comercial.pptx
+++ b/entregables/presentacion_comite_comercial.pptx
@@ -3103,7 +3103,7 @@
         </p:nvSpPr>
         <p:spPr>
           <a:xfrm>
-            <a:off x="762000" y="3733800"/>
+            <a:off x="609600" y="3143250"/>
             <a:ext cx="5715000" cy="190500"/>
           </a:xfrm>
           <a:prstGeom prst="rect">
@@ -3142,8 +3142,8 @@
         </p:nvSpPr>
         <p:spPr>
           <a:xfrm>
-            <a:off x="762000" y="4057650"/>
-            <a:ext cx="10477500" cy="857250"/>
+            <a:off x="609600" y="3467100"/>
+            <a:ext cx="10953750" cy="857250"/>
           </a:xfrm>
           <a:prstGeom prst="rect">
             <a:avLst/>
@@ -3199,7 +3199,7 @@
         </p:nvSpPr>
         <p:spPr>
           <a:xfrm>
-            <a:off x="762000" y="5029200"/>
+            <a:off x="609600" y="4438650"/>
             <a:ext cx="8953500" cy="666750"/>
           </a:xfrm>
           <a:prstGeom prst="rect">
@@ -3238,7 +3238,7 @@
         </p:nvSpPr>
         <p:spPr>
           <a:xfrm>
-            <a:off x="762000" y="6153150"/>
+            <a:off x="609600" y="6153150"/>
             <a:ext cx="4762500" cy="228600"/>
           </a:xfrm>
           <a:prstGeom prst="rect">
@@ -3373,7 +3373,7 @@
         </p:nvSpPr>
         <p:spPr>
           <a:xfrm>
-            <a:off x="609600" y="1524000"/>
+            <a:off x="609600" y="1581150"/>
             <a:ext cx="3390900" cy="190500"/>
           </a:xfrm>
           <a:prstGeom prst="rect">
@@ -3412,8 +3412,8 @@
         </p:nvSpPr>
         <p:spPr>
           <a:xfrm>
-            <a:off x="609600" y="1809750"/>
-            <a:ext cx="3390900" cy="1905000"/>
+            <a:off x="609600" y="1885950"/>
+            <a:ext cx="3390900" cy="2190750"/>
           </a:xfrm>
           <a:prstGeom prst="rect">
             <a:avLst/>
@@ -3428,11 +3428,11 @@
           <a:p>
             <a:pPr algn="l">
               <a:lnSpc>
-                <a:spcPct val="145000"/>
-              </a:lnSpc>
-            </a:pPr>
-            <a:r>
-              <a:rPr sz="1275" b="0">
+                <a:spcPct val="150000"/>
+              </a:lnSpc>
+            </a:pPr>
+            <a:r>
+              <a:rPr sz="1350" b="0">
                 <a:solidFill>
                   <a:srgbClr val="0B0B0B"/>
                 </a:solidFill>
@@ -3451,7 +3451,7 @@
         </p:nvSpPr>
         <p:spPr>
           <a:xfrm>
-            <a:off x="4391025" y="1524000"/>
+            <a:off x="4391025" y="1581150"/>
             <a:ext cx="3390900" cy="190500"/>
           </a:xfrm>
           <a:prstGeom prst="rect">
@@ -3490,8 +3490,8 @@
         </p:nvSpPr>
         <p:spPr>
           <a:xfrm>
-            <a:off x="4391025" y="1809750"/>
-            <a:ext cx="3390900" cy="1905000"/>
+            <a:off x="4391025" y="1885950"/>
+            <a:ext cx="3390900" cy="2190750"/>
           </a:xfrm>
           <a:prstGeom prst="rect">
             <a:avLst/>
@@ -3506,11 +3506,11 @@
           <a:p>
             <a:pPr algn="l">
               <a:lnSpc>
-                <a:spcPct val="145000"/>
-              </a:lnSpc>
-            </a:pPr>
-            <a:r>
-              <a:rPr sz="1275" b="0">
+                <a:spcPct val="150000"/>
+              </a:lnSpc>
+            </a:pPr>
+            <a:r>
+              <a:rPr sz="1350" b="0">
                 <a:solidFill>
                   <a:srgbClr val="0B0B0B"/>
                 </a:solidFill>
@@ -3529,7 +3529,7 @@
         </p:nvSpPr>
         <p:spPr>
           <a:xfrm>
-            <a:off x="8172450" y="1524000"/>
+            <a:off x="8172450" y="1581150"/>
             <a:ext cx="3390900" cy="190500"/>
           </a:xfrm>
           <a:prstGeom prst="rect">
@@ -3568,8 +3568,8 @@
         </p:nvSpPr>
         <p:spPr>
           <a:xfrm>
-            <a:off x="8172450" y="1809750"/>
-            <a:ext cx="3390900" cy="1905000"/>
+            <a:off x="8172450" y="1885950"/>
+            <a:ext cx="3390900" cy="2190750"/>
           </a:xfrm>
           <a:prstGeom prst="rect">
             <a:avLst/>
@@ -3584,11 +3584,11 @@
           <a:p>
             <a:pPr algn="l">
               <a:lnSpc>
-                <a:spcPct val="145000"/>
-              </a:lnSpc>
-            </a:pPr>
-            <a:r>
-              <a:rPr sz="1275" b="0">
+                <a:spcPct val="150000"/>
+              </a:lnSpc>
+            </a:pPr>
+            <a:r>
+              <a:rPr sz="1350" b="0">
                 <a:solidFill>
                   <a:srgbClr val="0B0B0B"/>
                 </a:solidFill>
@@ -3607,7 +3607,7 @@
         </p:nvSpPr>
         <p:spPr>
           <a:xfrm>
-            <a:off x="609600" y="5391150"/>
+            <a:off x="609600" y="4629150"/>
             <a:ext cx="3619500" cy="762000"/>
           </a:xfrm>
           <a:prstGeom prst="rect">
@@ -3646,8 +3646,8 @@
         </p:nvSpPr>
         <p:spPr>
           <a:xfrm>
-            <a:off x="3829050" y="5600700"/>
-            <a:ext cx="5905500" cy="571500"/>
+            <a:off x="3829050" y="4838700"/>
+            <a:ext cx="6096000" cy="571500"/>
           </a:xfrm>
           <a:prstGeom prst="rect">
             <a:avLst/>
@@ -6087,8 +6087,8 @@
         </p:nvSpPr>
         <p:spPr>
           <a:xfrm>
-            <a:off x="7886700" y="1123950"/>
-            <a:ext cx="3695700" cy="357188"/>
+            <a:off x="7886700" y="1181100"/>
+            <a:ext cx="3695700" cy="381000"/>
           </a:xfrm>
           <a:prstGeom prst="rect">
             <a:avLst/>
@@ -6107,7 +6107,7 @@
               </a:lnSpc>
             </a:pPr>
             <a:r>
-              <a:rPr sz="2250" b="1">
+              <a:rPr sz="2400" b="1">
                 <a:solidFill>
                   <a:srgbClr val="0B0B0B"/>
                 </a:solidFill>
@@ -6126,7 +6126,7 @@
         </p:nvSpPr>
         <p:spPr>
           <a:xfrm>
-            <a:off x="7886700" y="1500188"/>
+            <a:off x="7886700" y="1581150"/>
             <a:ext cx="3695700" cy="571500"/>
           </a:xfrm>
           <a:prstGeom prst="rect">
@@ -6165,8 +6165,8 @@
         </p:nvSpPr>
         <p:spPr>
           <a:xfrm>
-            <a:off x="7886700" y="2095500"/>
-            <a:ext cx="3695700" cy="357188"/>
+            <a:off x="7886700" y="2381250"/>
+            <a:ext cx="3695700" cy="381000"/>
           </a:xfrm>
           <a:prstGeom prst="rect">
             <a:avLst/>
@@ -6185,7 +6185,7 @@
               </a:lnSpc>
             </a:pPr>
             <a:r>
-              <a:rPr sz="2250" b="1">
+              <a:rPr sz="2400" b="1">
                 <a:solidFill>
                   <a:srgbClr val="0B0B0B"/>
                 </a:solidFill>
@@ -6204,7 +6204,7 @@
         </p:nvSpPr>
         <p:spPr>
           <a:xfrm>
-            <a:off x="7886700" y="2471738"/>
+            <a:off x="7886700" y="2781300"/>
             <a:ext cx="3695700" cy="571500"/>
           </a:xfrm>
           <a:prstGeom prst="rect">
@@ -6243,8 +6243,8 @@
         </p:nvSpPr>
         <p:spPr>
           <a:xfrm>
-            <a:off x="7886700" y="3067050"/>
-            <a:ext cx="3695700" cy="357188"/>
+            <a:off x="7886700" y="3581400"/>
+            <a:ext cx="3695700" cy="381000"/>
           </a:xfrm>
           <a:prstGeom prst="rect">
             <a:avLst/>
@@ -6263,7 +6263,7 @@
               </a:lnSpc>
             </a:pPr>
             <a:r>
-              <a:rPr sz="2250" b="1">
+              <a:rPr sz="2400" b="1">
                 <a:solidFill>
                   <a:srgbClr val="0B0B0B"/>
                 </a:solidFill>
@@ -6282,7 +6282,7 @@
         </p:nvSpPr>
         <p:spPr>
           <a:xfrm>
-            <a:off x="7886700" y="3443288"/>
+            <a:off x="7886700" y="3981450"/>
             <a:ext cx="3695700" cy="571500"/>
           </a:xfrm>
           <a:prstGeom prst="rect">
@@ -10403,7 +10403,7 @@
             <a:r>
               <a:rPr sz="1200" b="1">
                 <a:solidFill>
-                  <a:srgbClr val="1C5CAB"/>
+                  <a:srgbClr val="0B0B0B"/>
                 </a:solidFill>
                 <a:latin typeface="Segoe UI"/>
               </a:rPr>
@@ -10481,7 +10481,7 @@
             <a:r>
               <a:rPr sz="1200" b="1">
                 <a:solidFill>
-                  <a:srgbClr val="3987E5"/>
+                  <a:srgbClr val="0B0B0B"/>
                 </a:solidFill>
                 <a:latin typeface="Segoe UI"/>
               </a:rPr>
@@ -10559,7 +10559,7 @@
             <a:r>
               <a:rPr sz="1200" b="1">
                 <a:solidFill>
-                  <a:srgbClr val="86B6EF"/>
+                  <a:srgbClr val="0B0B0B"/>
                 </a:solidFill>
                 <a:latin typeface="Segoe UI"/>
               </a:rPr>
@@ -10650,7 +10650,7 @@
         </p:nvSpPr>
         <p:spPr>
           <a:xfrm>
-            <a:off x="742950" y="1676400"/>
+            <a:off x="742950" y="1704975"/>
             <a:ext cx="1714500" cy="228600"/>
           </a:xfrm>
           <a:prstGeom prst="rect">
@@ -10689,7 +10689,7 @@
         </p:nvSpPr>
         <p:spPr>
           <a:xfrm>
-            <a:off x="2038350" y="1676400"/>
+            <a:off x="2038350" y="1704975"/>
             <a:ext cx="1714500" cy="228600"/>
           </a:xfrm>
           <a:prstGeom prst="rect">
@@ -10728,7 +10728,7 @@
         </p:nvSpPr>
         <p:spPr>
           <a:xfrm>
-            <a:off x="3752850" y="1676400"/>
+            <a:off x="3752850" y="1704975"/>
             <a:ext cx="1714500" cy="228600"/>
           </a:xfrm>
           <a:prstGeom prst="rect">
@@ -10767,7 +10767,7 @@
         </p:nvSpPr>
         <p:spPr>
           <a:xfrm>
-            <a:off x="5467350" y="1676400"/>
+            <a:off x="5467350" y="1704975"/>
             <a:ext cx="1714500" cy="228600"/>
           </a:xfrm>
           <a:prstGeom prst="rect">
@@ -10806,7 +10806,7 @@
         </p:nvCxnSpPr>
         <p:spPr>
           <a:xfrm>
-            <a:off x="609600" y="2019300"/>
+            <a:off x="609600" y="2076450"/>
             <a:ext cx="6572250" cy="0"/>
           </a:xfrm>
           <a:prstGeom prst="line">
@@ -10841,7 +10841,7 @@
         </p:nvSpPr>
         <p:spPr>
           <a:xfrm>
-            <a:off x="742950" y="2133600"/>
+            <a:off x="742950" y="2219325"/>
             <a:ext cx="1714500" cy="228600"/>
           </a:xfrm>
           <a:prstGeom prst="rect">
@@ -10880,7 +10880,7 @@
         </p:nvSpPr>
         <p:spPr>
           <a:xfrm>
-            <a:off x="2038350" y="2133600"/>
+            <a:off x="2038350" y="2219325"/>
             <a:ext cx="1714500" cy="228600"/>
           </a:xfrm>
           <a:prstGeom prst="rect">
@@ -10919,7 +10919,7 @@
         </p:nvSpPr>
         <p:spPr>
           <a:xfrm>
-            <a:off x="3752850" y="2133600"/>
+            <a:off x="3752850" y="2219325"/>
             <a:ext cx="1714500" cy="228600"/>
           </a:xfrm>
           <a:prstGeom prst="rect">
@@ -10958,7 +10958,7 @@
         </p:nvSpPr>
         <p:spPr>
           <a:xfrm>
-            <a:off x="5467350" y="2133600"/>
+            <a:off x="5467350" y="2219325"/>
             <a:ext cx="1714500" cy="228600"/>
           </a:xfrm>
           <a:prstGeom prst="rect">
@@ -10997,7 +10997,7 @@
         </p:nvCxnSpPr>
         <p:spPr>
           <a:xfrm>
-            <a:off x="609600" y="2476500"/>
+            <a:off x="609600" y="2590800"/>
             <a:ext cx="6572250" cy="0"/>
           </a:xfrm>
           <a:prstGeom prst="line">
@@ -11032,7 +11032,7 @@
         </p:nvSpPr>
         <p:spPr>
           <a:xfrm>
-            <a:off x="742950" y="2590800"/>
+            <a:off x="742950" y="2733675"/>
             <a:ext cx="1714500" cy="228600"/>
           </a:xfrm>
           <a:prstGeom prst="rect">
@@ -11071,7 +11071,7 @@
         </p:nvSpPr>
         <p:spPr>
           <a:xfrm>
-            <a:off x="2038350" y="2590800"/>
+            <a:off x="2038350" y="2733675"/>
             <a:ext cx="1714500" cy="228600"/>
           </a:xfrm>
           <a:prstGeom prst="rect">
@@ -11110,7 +11110,7 @@
         </p:nvSpPr>
         <p:spPr>
           <a:xfrm>
-            <a:off x="3752850" y="2590800"/>
+            <a:off x="3752850" y="2733675"/>
             <a:ext cx="1714500" cy="228600"/>
           </a:xfrm>
           <a:prstGeom prst="rect">
@@ -11149,7 +11149,7 @@
         </p:nvSpPr>
         <p:spPr>
           <a:xfrm>
-            <a:off x="5467350" y="2590800"/>
+            <a:off x="5467350" y="2733675"/>
             <a:ext cx="1714500" cy="228600"/>
           </a:xfrm>
           <a:prstGeom prst="rect">
@@ -11188,7 +11188,7 @@
         </p:nvCxnSpPr>
         <p:spPr>
           <a:xfrm>
-            <a:off x="609600" y="2933700"/>
+            <a:off x="609600" y="3105150"/>
             <a:ext cx="6572250" cy="0"/>
           </a:xfrm>
           <a:prstGeom prst="line">
@@ -11223,7 +11223,7 @@
         </p:nvSpPr>
         <p:spPr>
           <a:xfrm>
-            <a:off x="742950" y="3048000"/>
+            <a:off x="742950" y="3248025"/>
             <a:ext cx="1714500" cy="228600"/>
           </a:xfrm>
           <a:prstGeom prst="rect">
@@ -11262,7 +11262,7 @@
         </p:nvSpPr>
         <p:spPr>
           <a:xfrm>
-            <a:off x="2038350" y="3048000"/>
+            <a:off x="2038350" y="3248025"/>
             <a:ext cx="1714500" cy="228600"/>
           </a:xfrm>
           <a:prstGeom prst="rect">
@@ -11301,7 +11301,7 @@
         </p:nvSpPr>
         <p:spPr>
           <a:xfrm>
-            <a:off x="3752850" y="3048000"/>
+            <a:off x="3752850" y="3248025"/>
             <a:ext cx="1714500" cy="228600"/>
           </a:xfrm>
           <a:prstGeom prst="rect">
@@ -11340,7 +11340,7 @@
         </p:nvSpPr>
         <p:spPr>
           <a:xfrm>
-            <a:off x="5467350" y="3048000"/>
+            <a:off x="5467350" y="3248025"/>
             <a:ext cx="1714500" cy="228600"/>
           </a:xfrm>
           <a:prstGeom prst="rect">
@@ -11379,7 +11379,7 @@
         </p:nvCxnSpPr>
         <p:spPr>
           <a:xfrm>
-            <a:off x="609600" y="3390900"/>
+            <a:off x="609600" y="3619500"/>
             <a:ext cx="6572250" cy="0"/>
           </a:xfrm>
           <a:prstGeom prst="line">
@@ -11414,7 +11414,7 @@
         </p:nvSpPr>
         <p:spPr>
           <a:xfrm>
-            <a:off x="742950" y="3505200"/>
+            <a:off x="742950" y="3762375"/>
             <a:ext cx="1714500" cy="228600"/>
           </a:xfrm>
           <a:prstGeom prst="rect">
@@ -11453,7 +11453,7 @@
         </p:nvSpPr>
         <p:spPr>
           <a:xfrm>
-            <a:off x="2038350" y="3505200"/>
+            <a:off x="2038350" y="3762375"/>
             <a:ext cx="1714500" cy="228600"/>
           </a:xfrm>
           <a:prstGeom prst="rect">
@@ -11492,7 +11492,7 @@
         </p:nvSpPr>
         <p:spPr>
           <a:xfrm>
-            <a:off x="3752850" y="3505200"/>
+            <a:off x="3752850" y="3762375"/>
             <a:ext cx="1714500" cy="228600"/>
           </a:xfrm>
           <a:prstGeom prst="rect">
@@ -11531,7 +11531,7 @@
         </p:nvSpPr>
         <p:spPr>
           <a:xfrm>
-            <a:off x="5467350" y="3505200"/>
+            <a:off x="5467350" y="3762375"/>
             <a:ext cx="1714500" cy="228600"/>
           </a:xfrm>
           <a:prstGeom prst="rect">
@@ -11570,7 +11570,7 @@
         </p:nvCxnSpPr>
         <p:spPr>
           <a:xfrm>
-            <a:off x="609600" y="3848100"/>
+            <a:off x="609600" y="4133850"/>
             <a:ext cx="6572250" cy="0"/>
           </a:xfrm>
           <a:prstGeom prst="line">
@@ -11605,7 +11605,7 @@
         </p:nvSpPr>
         <p:spPr>
           <a:xfrm>
-            <a:off x="742950" y="3962400"/>
+            <a:off x="742950" y="4276725"/>
             <a:ext cx="1714500" cy="228600"/>
           </a:xfrm>
           <a:prstGeom prst="rect">
@@ -11644,7 +11644,7 @@
         </p:nvSpPr>
         <p:spPr>
           <a:xfrm>
-            <a:off x="2038350" y="3962400"/>
+            <a:off x="2038350" y="4276725"/>
             <a:ext cx="1714500" cy="228600"/>
           </a:xfrm>
           <a:prstGeom prst="rect">
@@ -11683,7 +11683,7 @@
         </p:nvSpPr>
         <p:spPr>
           <a:xfrm>
-            <a:off x="3752850" y="3962400"/>
+            <a:off x="3752850" y="4276725"/>
             <a:ext cx="1714500" cy="228600"/>
           </a:xfrm>
           <a:prstGeom prst="rect">
@@ -11722,7 +11722,7 @@
         </p:nvSpPr>
         <p:spPr>
           <a:xfrm>
-            <a:off x="5467350" y="3962400"/>
+            <a:off x="5467350" y="4276725"/>
             <a:ext cx="1714500" cy="228600"/>
           </a:xfrm>
           <a:prstGeom prst="rect">
@@ -11761,7 +11761,7 @@
         </p:nvCxnSpPr>
         <p:spPr>
           <a:xfrm>
-            <a:off x="609600" y="4305300"/>
+            <a:off x="609600" y="4648200"/>
             <a:ext cx="6572250" cy="0"/>
           </a:xfrm>
           <a:prstGeom prst="line">
@@ -11796,7 +11796,7 @@
         </p:nvSpPr>
         <p:spPr>
           <a:xfrm>
-            <a:off x="609600" y="4419600"/>
+            <a:off x="609600" y="4762500"/>
             <a:ext cx="6572250" cy="190500"/>
           </a:xfrm>
           <a:prstGeom prst="rect">
@@ -16087,7 +16087,7 @@
                 </a:solidFill>
                 <a:latin typeface="Segoe UI"/>
               </a:rPr>
-              <a:t>Curva incierta, solo del 60 % al 100 % del efecto es causal y se ejecuta del 70 % al 100 % del plan.</a:t>
+              <a:t>Curva incierta, solo del 60 % al 100 % del efecto es causal y se ejecuta del 70 % al 100 % del plan. La línea discontinua es la estimación central, 2,44 M€.</a:t>
             </a:r>
           </a:p>
         </p:txBody>
@@ -16100,7 +16100,7 @@
         </p:nvSpPr>
         <p:spPr>
           <a:xfrm>
-            <a:off x="7695171" y="2903784"/>
+            <a:off x="7695171" y="2941884"/>
             <a:ext cx="144399" cy="106116"/>
           </a:xfrm>
           <a:prstGeom prst="rect">
@@ -16144,7 +16144,7 @@
         </p:nvSpPr>
         <p:spPr>
           <a:xfrm>
-            <a:off x="7849095" y="2529064"/>
+            <a:off x="7849095" y="2567164"/>
             <a:ext cx="175184" cy="480836"/>
           </a:xfrm>
           <a:prstGeom prst="rect">
@@ -16188,7 +16188,7 @@
         </p:nvSpPr>
         <p:spPr>
           <a:xfrm>
-            <a:off x="8033804" y="2227298"/>
+            <a:off x="8033804" y="2265398"/>
             <a:ext cx="144399" cy="782602"/>
           </a:xfrm>
           <a:prstGeom prst="rect">
@@ -16232,7 +16232,7 @@
         </p:nvSpPr>
         <p:spPr>
           <a:xfrm>
-            <a:off x="8187728" y="2154343"/>
+            <a:off x="8187728" y="2192443"/>
             <a:ext cx="175184" cy="855557"/>
           </a:xfrm>
           <a:prstGeom prst="rect">
@@ -16276,7 +16276,7 @@
         </p:nvSpPr>
         <p:spPr>
           <a:xfrm>
-            <a:off x="8372437" y="2260459"/>
+            <a:off x="8372437" y="2298559"/>
             <a:ext cx="175184" cy="749441"/>
           </a:xfrm>
           <a:prstGeom prst="rect">
@@ -16320,7 +16320,7 @@
         </p:nvSpPr>
         <p:spPr>
           <a:xfrm>
-            <a:off x="8557146" y="2237246"/>
+            <a:off x="8557146" y="2275346"/>
             <a:ext cx="144399" cy="772654"/>
           </a:xfrm>
           <a:prstGeom prst="rect">
@@ -16364,7 +16364,7 @@
         </p:nvSpPr>
         <p:spPr>
           <a:xfrm>
-            <a:off x="8711070" y="2114550"/>
+            <a:off x="8711070" y="2152650"/>
             <a:ext cx="175184" cy="895350"/>
           </a:xfrm>
           <a:prstGeom prst="rect">
@@ -16408,7 +16408,7 @@
         </p:nvSpPr>
         <p:spPr>
           <a:xfrm>
-            <a:off x="8895778" y="2260459"/>
+            <a:off x="8895778" y="2298559"/>
             <a:ext cx="144399" cy="749441"/>
           </a:xfrm>
           <a:prstGeom prst="rect">
@@ -16452,7 +16452,7 @@
         </p:nvSpPr>
         <p:spPr>
           <a:xfrm>
-            <a:off x="9049702" y="2253827"/>
+            <a:off x="9049702" y="2291927"/>
             <a:ext cx="175184" cy="756073"/>
           </a:xfrm>
           <a:prstGeom prst="rect">
@@ -16496,7 +16496,7 @@
         </p:nvSpPr>
         <p:spPr>
           <a:xfrm>
-            <a:off x="9234411" y="2290304"/>
+            <a:off x="9234411" y="2328404"/>
             <a:ext cx="144399" cy="719596"/>
           </a:xfrm>
           <a:prstGeom prst="rect">
@@ -16540,7 +16540,7 @@
         </p:nvSpPr>
         <p:spPr>
           <a:xfrm>
-            <a:off x="9388335" y="2330097"/>
+            <a:off x="9388335" y="2368197"/>
             <a:ext cx="175184" cy="679803"/>
           </a:xfrm>
           <a:prstGeom prst="rect">
@@ -16584,7 +16584,7 @@
         </p:nvSpPr>
         <p:spPr>
           <a:xfrm>
-            <a:off x="9573044" y="2240562"/>
+            <a:off x="9573044" y="2278662"/>
             <a:ext cx="175184" cy="769338"/>
           </a:xfrm>
           <a:prstGeom prst="rect">
@@ -16628,7 +16628,7 @@
         </p:nvSpPr>
         <p:spPr>
           <a:xfrm>
-            <a:off x="9757753" y="2154343"/>
+            <a:off x="9757753" y="2192443"/>
             <a:ext cx="144399" cy="855557"/>
           </a:xfrm>
           <a:prstGeom prst="rect">
@@ -16672,7 +16672,7 @@
         </p:nvSpPr>
         <p:spPr>
           <a:xfrm>
-            <a:off x="9911677" y="2273723"/>
+            <a:off x="9911677" y="2311823"/>
             <a:ext cx="175184" cy="736177"/>
           </a:xfrm>
           <a:prstGeom prst="rect">
@@ -16716,7 +16716,7 @@
         </p:nvSpPr>
         <p:spPr>
           <a:xfrm>
-            <a:off x="10096386" y="2283672"/>
+            <a:off x="10096386" y="2321772"/>
             <a:ext cx="144399" cy="726228"/>
           </a:xfrm>
           <a:prstGeom prst="rect">
@@ -16760,7 +16760,7 @@
         </p:nvSpPr>
         <p:spPr>
           <a:xfrm>
-            <a:off x="10250310" y="2257143"/>
+            <a:off x="10250310" y="2295243"/>
             <a:ext cx="175184" cy="752757"/>
           </a:xfrm>
           <a:prstGeom prst="rect">
@@ -16804,7 +16804,7 @@
         </p:nvSpPr>
         <p:spPr>
           <a:xfrm>
-            <a:off x="10435018" y="2320149"/>
+            <a:off x="10435018" y="2358249"/>
             <a:ext cx="175184" cy="689751"/>
           </a:xfrm>
           <a:prstGeom prst="rect">
@@ -16848,7 +16848,7 @@
         </p:nvSpPr>
         <p:spPr>
           <a:xfrm>
-            <a:off x="10619727" y="2316833"/>
+            <a:off x="10619727" y="2354933"/>
             <a:ext cx="144399" cy="693067"/>
           </a:xfrm>
           <a:prstGeom prst="rect">
@@ -16892,7 +16892,7 @@
         </p:nvSpPr>
         <p:spPr>
           <a:xfrm>
-            <a:off x="10773651" y="2638496"/>
+            <a:off x="10773651" y="2676596"/>
             <a:ext cx="175184" cy="371404"/>
           </a:xfrm>
           <a:prstGeom prst="rect">
@@ -16936,7 +16936,7 @@
         </p:nvSpPr>
         <p:spPr>
           <a:xfrm>
-            <a:off x="10958360" y="2887204"/>
+            <a:off x="10958360" y="2925304"/>
             <a:ext cx="144399" cy="122696"/>
           </a:xfrm>
           <a:prstGeom prst="rect">
@@ -16980,7 +16980,7 @@
         </p:nvCxnSpPr>
         <p:spPr>
           <a:xfrm>
-            <a:off x="8182966" y="1885950"/>
+            <a:off x="8182966" y="1924050"/>
             <a:ext cx="0" cy="1123950"/>
           </a:xfrm>
           <a:prstGeom prst="line">
@@ -17016,7 +17016,7 @@
         </p:nvSpPr>
         <p:spPr>
           <a:xfrm>
-            <a:off x="7885786" y="1732836"/>
+            <a:off x="7885786" y="1770936"/>
             <a:ext cx="594360" cy="150019"/>
           </a:xfrm>
           <a:prstGeom prst="rect">
@@ -17055,7 +17055,7 @@
         </p:nvCxnSpPr>
         <p:spPr>
           <a:xfrm>
-            <a:off x="9352788" y="1885950"/>
+            <a:off x="9352788" y="1924050"/>
             <a:ext cx="0" cy="1123950"/>
           </a:xfrm>
           <a:prstGeom prst="line">
@@ -17090,7 +17090,7 @@
         </p:nvSpPr>
         <p:spPr>
           <a:xfrm>
-            <a:off x="8935593" y="1732836"/>
+            <a:off x="8935593" y="1770936"/>
             <a:ext cx="834390" cy="150019"/>
           </a:xfrm>
           <a:prstGeom prst="rect">
@@ -17129,7 +17129,7 @@
         </p:nvCxnSpPr>
         <p:spPr>
           <a:xfrm>
-            <a:off x="10553395" y="1885950"/>
+            <a:off x="10553395" y="1924050"/>
             <a:ext cx="0" cy="1123950"/>
           </a:xfrm>
           <a:prstGeom prst="line">
@@ -17165,7 +17165,7 @@
         </p:nvSpPr>
         <p:spPr>
           <a:xfrm>
-            <a:off x="10256215" y="1732836"/>
+            <a:off x="10256215" y="1770936"/>
             <a:ext cx="594360" cy="150019"/>
           </a:xfrm>
           <a:prstGeom prst="rect">
@@ -17204,7 +17204,7 @@
         </p:nvCxnSpPr>
         <p:spPr>
           <a:xfrm>
-            <a:off x="11018618" y="2076450"/>
+            <a:off x="11018618" y="2114550"/>
             <a:ext cx="0" cy="933450"/>
           </a:xfrm>
           <a:prstGeom prst="line">
@@ -17232,54 +17232,15 @@
           </a:fontRef>
         </p:style>
       </p:cxnSp>
-      <p:sp>
-        <p:nvSpPr>
-          <p:cNvPr id="71" name="TextBox 70"/>
-          <p:cNvSpPr txBox="1"/>
-          <p:nvPr/>
-        </p:nvSpPr>
-        <p:spPr>
-          <a:xfrm>
-            <a:off x="10136603" y="1923336"/>
-            <a:ext cx="834390" cy="150019"/>
-          </a:xfrm>
-          <a:prstGeom prst="rect">
-            <a:avLst/>
-          </a:prstGeom>
-          <a:noFill/>
-        </p:spPr>
-        <p:txBody>
-          <a:bodyPr wrap="none" lIns="0" rIns="0" tIns="0" bIns="0" anchor="t">
-            <a:noAutofit/>
-          </a:bodyPr>
-          <a:lstStyle/>
-          <a:p>
-            <a:pPr algn="r">
-              <a:lnSpc>
-                <a:spcPct val="120000"/>
-              </a:lnSpc>
-            </a:pPr>
-            <a:r>
-              <a:rPr sz="787" b="1">
-                <a:solidFill>
-                  <a:srgbClr val="0B0B0B"/>
-                </a:solidFill>
-                <a:latin typeface="Segoe UI"/>
-              </a:rPr>
-              <a:t>central 2,44</a:t>
-            </a:r>
-          </a:p>
-        </p:txBody>
-      </p:sp>
       <p:cxnSp>
         <p:nvCxnSpPr>
-          <p:cNvPr id="72" name="Connector 71"/>
+          <p:cNvPr id="71" name="Connector 70"/>
           <p:cNvCxnSpPr/>
           <p:nvPr/>
         </p:nvCxnSpPr>
         <p:spPr>
           <a:xfrm>
-            <a:off x="7505700" y="3009900"/>
+            <a:off x="7505700" y="3048000"/>
             <a:ext cx="3848100" cy="0"/>
           </a:xfrm>
           <a:prstGeom prst="line">
@@ -17308,13 +17269,52 @@
       </p:cxnSp>
       <p:sp>
         <p:nvSpPr>
+          <p:cNvPr id="72" name="TextBox 71"/>
+          <p:cNvSpPr txBox="1"/>
+          <p:nvPr/>
+        </p:nvSpPr>
+        <p:spPr>
+          <a:xfrm>
+            <a:off x="7666387" y="3104436"/>
+            <a:ext cx="294322" cy="150019"/>
+          </a:xfrm>
+          <a:prstGeom prst="rect">
+            <a:avLst/>
+          </a:prstGeom>
+          <a:noFill/>
+        </p:spPr>
+        <p:txBody>
+          <a:bodyPr wrap="none" lIns="0" rIns="0" tIns="0" bIns="0" anchor="t">
+            <a:noAutofit/>
+          </a:bodyPr>
+          <a:lstStyle/>
+          <a:p>
+            <a:pPr algn="ctr">
+              <a:lnSpc>
+                <a:spcPct val="120000"/>
+              </a:lnSpc>
+            </a:pPr>
+            <a:r>
+              <a:rPr sz="787" b="0">
+                <a:solidFill>
+                  <a:srgbClr val="52514E"/>
+                </a:solidFill>
+                <a:latin typeface="Segoe UI"/>
+              </a:rPr>
+              <a:t>1,4</a:t>
+            </a:r>
+          </a:p>
+        </p:txBody>
+      </p:sp>
+      <p:sp>
+        <p:nvSpPr>
           <p:cNvPr id="73" name="TextBox 72"/>
           <p:cNvSpPr txBox="1"/>
           <p:nvPr/>
         </p:nvSpPr>
         <p:spPr>
           <a:xfrm>
-            <a:off x="7666387" y="3066336"/>
+            <a:off x="8282083" y="3104436"/>
             <a:ext cx="294322" cy="150019"/>
           </a:xfrm>
           <a:prstGeom prst="rect">
@@ -17340,7 +17340,7 @@
                 </a:solidFill>
                 <a:latin typeface="Segoe UI"/>
               </a:rPr>
-              <a:t>1,4</a:t>
+              <a:t>1,6</a:t>
             </a:r>
           </a:p>
         </p:txBody>
@@ -17353,7 +17353,7 @@
         </p:nvSpPr>
         <p:spPr>
           <a:xfrm>
-            <a:off x="8282083" y="3066336"/>
+            <a:off x="8897779" y="3104436"/>
             <a:ext cx="294322" cy="150019"/>
           </a:xfrm>
           <a:prstGeom prst="rect">
@@ -17379,7 +17379,7 @@
                 </a:solidFill>
                 <a:latin typeface="Segoe UI"/>
               </a:rPr>
-              <a:t>1,6</a:t>
+              <a:t>1,8</a:t>
             </a:r>
           </a:p>
         </p:txBody>
@@ -17392,7 +17392,7 @@
         </p:nvSpPr>
         <p:spPr>
           <a:xfrm>
-            <a:off x="8897779" y="3066336"/>
+            <a:off x="9513475" y="3104436"/>
             <a:ext cx="294322" cy="150019"/>
           </a:xfrm>
           <a:prstGeom prst="rect">
@@ -17418,7 +17418,7 @@
                 </a:solidFill>
                 <a:latin typeface="Segoe UI"/>
               </a:rPr>
-              <a:t>1,8</a:t>
+              <a:t>2,0</a:t>
             </a:r>
           </a:p>
         </p:txBody>
@@ -17431,7 +17431,7 @@
         </p:nvSpPr>
         <p:spPr>
           <a:xfrm>
-            <a:off x="9513475" y="3066336"/>
+            <a:off x="10129171" y="3104436"/>
             <a:ext cx="294322" cy="150019"/>
           </a:xfrm>
           <a:prstGeom prst="rect">
@@ -17457,7 +17457,7 @@
                 </a:solidFill>
                 <a:latin typeface="Segoe UI"/>
               </a:rPr>
-              <a:t>2,0</a:t>
+              <a:t>2,2</a:t>
             </a:r>
           </a:p>
         </p:txBody>
@@ -17470,7 +17470,7 @@
         </p:nvSpPr>
         <p:spPr>
           <a:xfrm>
-            <a:off x="10129171" y="3066336"/>
+            <a:off x="10744867" y="3104436"/>
             <a:ext cx="294322" cy="150019"/>
           </a:xfrm>
           <a:prstGeom prst="rect">
@@ -17496,7 +17496,7 @@
                 </a:solidFill>
                 <a:latin typeface="Segoe UI"/>
               </a:rPr>
-              <a:t>2,2</a:t>
+              <a:t>2,4</a:t>
             </a:r>
           </a:p>
         </p:txBody>
@@ -17504,45 +17504,6 @@
       <p:sp>
         <p:nvSpPr>
           <p:cNvPr id="78" name="TextBox 77"/>
-          <p:cNvSpPr txBox="1"/>
-          <p:nvPr/>
-        </p:nvSpPr>
-        <p:spPr>
-          <a:xfrm>
-            <a:off x="10744867" y="3066336"/>
-            <a:ext cx="294322" cy="150019"/>
-          </a:xfrm>
-          <a:prstGeom prst="rect">
-            <a:avLst/>
-          </a:prstGeom>
-          <a:noFill/>
-        </p:spPr>
-        <p:txBody>
-          <a:bodyPr wrap="none" lIns="0" rIns="0" tIns="0" bIns="0" anchor="t">
-            <a:noAutofit/>
-          </a:bodyPr>
-          <a:lstStyle/>
-          <a:p>
-            <a:pPr algn="ctr">
-              <a:lnSpc>
-                <a:spcPct val="120000"/>
-              </a:lnSpc>
-            </a:pPr>
-            <a:r>
-              <a:rPr sz="787" b="0">
-                <a:solidFill>
-                  <a:srgbClr val="52514E"/>
-                </a:solidFill>
-                <a:latin typeface="Segoe UI"/>
-              </a:rPr>
-              <a:t>2,4</a:t>
-            </a:r>
-          </a:p>
-        </p:txBody>
-      </p:sp>
-      <p:sp>
-        <p:nvSpPr>
-          <p:cNvPr id="79" name="TextBox 78"/>
           <p:cNvSpPr txBox="1"/>
           <p:nvPr/>
         </p:nvSpPr>
@@ -17581,7 +17542,7 @@
       </p:sp>
       <p:sp>
         <p:nvSpPr>
-          <p:cNvPr id="80" name="TextBox 79"/>
+          <p:cNvPr id="79" name="TextBox 78"/>
           <p:cNvSpPr txBox="1"/>
           <p:nvPr/>
         </p:nvSpPr>
@@ -17620,7 +17581,7 @@
       </p:sp>
       <p:sp>
         <p:nvSpPr>
-          <p:cNvPr id="81" name="TextBox 80"/>
+          <p:cNvPr id="80" name="TextBox 79"/>
           <p:cNvSpPr txBox="1"/>
           <p:nvPr/>
         </p:nvSpPr>
@@ -17659,7 +17620,7 @@
       </p:sp>
       <p:sp>
         <p:nvSpPr>
-          <p:cNvPr id="82" name="TextBox 81"/>
+          <p:cNvPr id="81" name="TextBox 80"/>
           <p:cNvSpPr txBox="1"/>
           <p:nvPr/>
         </p:nvSpPr>
@@ -17698,7 +17659,7 @@
       </p:sp>
       <p:sp>
         <p:nvSpPr>
-          <p:cNvPr id="83" name="TextBox 82"/>
+          <p:cNvPr id="82" name="TextBox 81"/>
           <p:cNvSpPr txBox="1"/>
           <p:nvPr/>
         </p:nvSpPr>
@@ -17737,7 +17698,7 @@
       </p:sp>
       <p:sp>
         <p:nvSpPr>
-          <p:cNvPr id="84" name="TextBox 83"/>
+          <p:cNvPr id="83" name="TextBox 82"/>
           <p:cNvSpPr txBox="1"/>
           <p:nvPr/>
         </p:nvSpPr>
@@ -17776,7 +17737,7 @@
       </p:sp>
       <p:sp>
         <p:nvSpPr>
-          <p:cNvPr id="85" name="TextBox 84"/>
+          <p:cNvPr id="84" name="TextBox 83"/>
           <p:cNvSpPr txBox="1"/>
           <p:nvPr/>
         </p:nvSpPr>
@@ -17815,7 +17776,7 @@
       </p:sp>
       <p:sp>
         <p:nvSpPr>
-          <p:cNvPr id="86" name="TextBox 85"/>
+          <p:cNvPr id="85" name="TextBox 84"/>
           <p:cNvSpPr txBox="1"/>
           <p:nvPr/>
         </p:nvSpPr>
@@ -17854,7 +17815,7 @@
       </p:sp>
       <p:sp>
         <p:nvSpPr>
-          <p:cNvPr id="87" name="TextBox 86"/>
+          <p:cNvPr id="86" name="TextBox 85"/>
           <p:cNvSpPr txBox="1"/>
           <p:nvPr/>
         </p:nvSpPr>
@@ -17893,7 +17854,7 @@
       </p:sp>
       <p:cxnSp>
         <p:nvCxnSpPr>
-          <p:cNvPr id="88" name="Connector 87"/>
+          <p:cNvPr id="87" name="Connector 86"/>
           <p:cNvCxnSpPr/>
           <p:nvPr/>
         </p:nvCxnSpPr>
@@ -17928,7 +17889,7 @@
       </p:cxnSp>
       <p:sp>
         <p:nvSpPr>
-          <p:cNvPr id="89" name="TextBox 88"/>
+          <p:cNvPr id="88" name="TextBox 87"/>
           <p:cNvSpPr txBox="1"/>
           <p:nvPr/>
         </p:nvSpPr>
@@ -17967,7 +17928,7 @@
       </p:sp>
       <p:sp>
         <p:nvSpPr>
-          <p:cNvPr id="90" name="TextBox 89"/>
+          <p:cNvPr id="89" name="TextBox 88"/>
           <p:cNvSpPr txBox="1"/>
           <p:nvPr/>
         </p:nvSpPr>
@@ -18006,7 +17967,7 @@
       </p:sp>
       <p:cxnSp>
         <p:nvCxnSpPr>
-          <p:cNvPr id="91" name="Connector 90"/>
+          <p:cNvPr id="90" name="Connector 89"/>
           <p:cNvCxnSpPr/>
           <p:nvPr/>
         </p:nvCxnSpPr>
@@ -18041,7 +18002,7 @@
       </p:cxnSp>
       <p:sp>
         <p:nvSpPr>
-          <p:cNvPr id="92" name="TextBox 91"/>
+          <p:cNvPr id="91" name="TextBox 90"/>
           <p:cNvSpPr txBox="1"/>
           <p:nvPr/>
         </p:nvSpPr>
@@ -18080,7 +18041,7 @@
       </p:sp>
       <p:sp>
         <p:nvSpPr>
-          <p:cNvPr id="93" name="TextBox 92"/>
+          <p:cNvPr id="92" name="TextBox 91"/>
           <p:cNvSpPr txBox="1"/>
           <p:nvPr/>
         </p:nvSpPr>
@@ -18119,7 +18080,7 @@
       </p:sp>
       <p:cxnSp>
         <p:nvCxnSpPr>
-          <p:cNvPr id="94" name="Connector 93"/>
+          <p:cNvPr id="93" name="Connector 92"/>
           <p:cNvCxnSpPr/>
           <p:nvPr/>
         </p:nvCxnSpPr>
@@ -18154,7 +18115,7 @@
       </p:cxnSp>
       <p:sp>
         <p:nvSpPr>
-          <p:cNvPr id="95" name="TextBox 94"/>
+          <p:cNvPr id="94" name="TextBox 93"/>
           <p:cNvSpPr txBox="1"/>
           <p:nvPr/>
         </p:nvSpPr>
@@ -18193,7 +18154,7 @@
       </p:sp>
       <p:sp>
         <p:nvSpPr>
-          <p:cNvPr id="96" name="TextBox 95"/>
+          <p:cNvPr id="95" name="TextBox 94"/>
           <p:cNvSpPr txBox="1"/>
           <p:nvPr/>
         </p:nvSpPr>
@@ -18232,7 +18193,7 @@
       </p:sp>
       <p:cxnSp>
         <p:nvCxnSpPr>
-          <p:cNvPr id="97" name="Connector 96"/>
+          <p:cNvPr id="96" name="Connector 95"/>
           <p:cNvCxnSpPr/>
           <p:nvPr/>
         </p:nvCxnSpPr>
@@ -18409,7 +18370,7 @@
         <p:spPr>
           <a:xfrm>
             <a:off x="609600" y="1447800"/>
-            <a:ext cx="3390900" cy="4191000"/>
+            <a:ext cx="3390900" cy="4476750"/>
           </a:xfrm>
           <a:prstGeom prst="rect">
             <a:avLst/>
@@ -18424,11 +18385,11 @@
           <a:p>
             <a:pPr algn="l">
               <a:lnSpc>
-                <a:spcPct val="150000"/>
-              </a:lnSpc>
-            </a:pPr>
-            <a:r>
-              <a:rPr sz="1162" b="0">
+                <a:spcPct val="155000"/>
+              </a:lnSpc>
+            </a:pPr>
+            <a:r>
+              <a:rPr sz="1237" b="0">
                 <a:solidFill>
                   <a:srgbClr val="0B0B0B"/>
                 </a:solidFill>
@@ -18487,7 +18448,7 @@
         <p:spPr>
           <a:xfrm>
             <a:off x="4391025" y="1447800"/>
-            <a:ext cx="3390900" cy="4191000"/>
+            <a:ext cx="3390900" cy="4476750"/>
           </a:xfrm>
           <a:prstGeom prst="rect">
             <a:avLst/>
@@ -18502,11 +18463,11 @@
           <a:p>
             <a:pPr algn="l">
               <a:lnSpc>
-                <a:spcPct val="150000"/>
-              </a:lnSpc>
-            </a:pPr>
-            <a:r>
-              <a:rPr sz="1162" b="0">
+                <a:spcPct val="155000"/>
+              </a:lnSpc>
+            </a:pPr>
+            <a:r>
+              <a:rPr sz="1237" b="0">
                 <a:solidFill>
                   <a:srgbClr val="0B0B0B"/>
                 </a:solidFill>
@@ -18565,7 +18526,7 @@
         <p:spPr>
           <a:xfrm>
             <a:off x="8172450" y="1447800"/>
-            <a:ext cx="3390900" cy="4191000"/>
+            <a:ext cx="3390900" cy="4476750"/>
           </a:xfrm>
           <a:prstGeom prst="rect">
             <a:avLst/>
@@ -18580,11 +18541,11 @@
           <a:p>
             <a:pPr algn="l">
               <a:lnSpc>
-                <a:spcPct val="150000"/>
-              </a:lnSpc>
-            </a:pPr>
-            <a:r>
-              <a:rPr sz="1162" b="0">
+                <a:spcPct val="155000"/>
+              </a:lnSpc>
+            </a:pPr>
+            <a:r>
+              <a:rPr sz="1237" b="0">
                 <a:solidFill>
                   <a:srgbClr val="0B0B0B"/>
                 </a:solidFill>

</xml_diff>

<commit_message>
docs: dejar claro que las frecuencias por segmento son medias por médico
</commit_message>
<xml_diff>
--- a/entregables/presentacion_comite_comercial.pptx
+++ b/entregables/presentacion_comite_comercial.pptx
@@ -3438,7 +3438,7 @@
                 </a:solidFill>
                 <a:latin typeface="Segoe UI"/>
               </a:rPr>
-              <a:t>Hoy un A recibe 13,3 visitas al año; un B, 4,1; un C, 1,5. La segmentación es correcta: solo 30 de 2.000 médicos están mal clasificados.</a:t>
+              <a:t>Hoy cada médico A recibe, de media, 13,3 visitas al año; cada B, 4,1; cada C, 1,5. La segmentación es correcta: solo 30 de 2.000 médicos están mal clasificados.</a:t>
             </a:r>
           </a:p>
         </p:txBody>
@@ -3594,7 +3594,7 @@
                 </a:solidFill>
                 <a:latin typeface="Segoe UI"/>
               </a:rPr>
-              <a:t>Pasar a ≈ 9-10 / 5 / 2 visitas al año (A / B / C), ajustadas por volumen, dentro de la cartera de cada delegado. Mismos delegados, mismas visitas, mismo coste.</a:t>
+              <a:t>Pasar a una media de 9-10 visitas al año por médico A, 5 por médico B y 2 por médico C, ajustada al volumen de cada uno y dentro de la cartera de cada delegado. Mismos delegados, mismas visitas, mismo coste.</a:t>
             </a:r>
           </a:p>
         </p:txBody>
@@ -6308,7 +6308,7 @@
                 </a:solidFill>
                 <a:latin typeface="Segoe UI"/>
               </a:rPr>
-              <a:t>visitas al año por médico A · B · C. La regla A &gt; B &gt; C se cumple; la pregunta es si esa intensidad la justifica la respuesta del médico</a:t>
+              <a:t>visitas al año por médico, de media, en los segmentos A · B · C. La regla A &gt; B &gt; C se cumple; la pregunta es si esa intensidad la justifica la respuesta del médico</a:t>
             </a:r>
           </a:p>
         </p:txBody>
@@ -12131,7 +12131,7 @@
                 </a:solidFill>
                 <a:latin typeface="Segoe UI"/>
               </a:rPr>
-              <a:t>Plan 2026: 9-10 / 5 / 2 visitas al año, ajustadas por volumen, dentro de la cartera de cada delegado</a:t>
+              <a:t>Plan 2026: una media de 9-10 / 5 / 2 visitas al año por médico A / B / C, ajustada al volumen de cada uno, dentro de su cartera</a:t>
             </a:r>
           </a:p>
         </p:txBody>

</xml_diff>